<commit_message>
Made near final poster
</commit_message>
<xml_diff>
--- a/Deliverables/Capstone_finalposter.pptx
+++ b/Deliverables/Capstone_finalposter.pptx
@@ -14,7 +14,7 @@
   <p:notesSz cx="7102475" cy="9388475"/>
   <p:embeddedFontLst>
     <p:embeddedFont>
-      <p:font typeface="Roboto Condensed ExtraBold" panose="02000000000000000000" pitchFamily="2" charset="0"/>
+      <p:font typeface="Roboto Condensed ExtraBold" panose="020B0604020202020204" charset="0"/>
       <p:regular r:id="rId4"/>
       <p:bold r:id="rId5"/>
       <p:italic r:id="rId6"/>
@@ -5202,36 +5202,6 @@
           <a:chExt cx="0" cy="0"/>
         </a:xfrm>
       </p:grpSpPr>
-      <p:pic>
-        <p:nvPicPr>
-          <p:cNvPr id="19" name="Picture 18">
-            <a:extLst>
-              <a:ext uri="{FF2B5EF4-FFF2-40B4-BE49-F238E27FC236}">
-                <a16:creationId xmlns:a16="http://schemas.microsoft.com/office/drawing/2014/main" id="{2CC6CBB6-6BF4-916B-E98F-B1C313931514}"/>
-              </a:ext>
-            </a:extLst>
-          </p:cNvPr>
-          <p:cNvPicPr>
-            <a:picLocks noChangeAspect="1"/>
-          </p:cNvPicPr>
-          <p:nvPr/>
-        </p:nvPicPr>
-        <p:blipFill>
-          <a:blip r:embed="rId4"/>
-          <a:stretch>
-            <a:fillRect/>
-          </a:stretch>
-        </p:blipFill>
-        <p:spPr>
-          <a:xfrm>
-            <a:off x="4457958" y="20982273"/>
-            <a:ext cx="22677860" cy="9103505"/>
-          </a:xfrm>
-          <a:prstGeom prst="rect">
-            <a:avLst/>
-          </a:prstGeom>
-        </p:spPr>
-      </p:pic>
       <p:graphicFrame>
         <p:nvGraphicFramePr>
           <p:cNvPr id="4" name="Table 3">
@@ -5247,14 +5217,14 @@
           <p:nvPr>
             <p:extLst>
               <p:ext uri="{D42A27DB-BD31-4B8C-83A1-F6EECF244321}">
-                <p14:modId xmlns:p14="http://schemas.microsoft.com/office/powerpoint/2010/main" val="4265571011"/>
+                <p14:modId xmlns:p14="http://schemas.microsoft.com/office/powerpoint/2010/main" val="110385562"/>
               </p:ext>
             </p:extLst>
           </p:nvPr>
         </p:nvGraphicFramePr>
         <p:xfrm>
           <a:off x="28376097" y="8101360"/>
-          <a:ext cx="14143493" cy="24175720"/>
+          <a:ext cx="14143493" cy="24059487"/>
         </p:xfrm>
         <a:graphic>
           <a:graphicData uri="http://schemas.openxmlformats.org/drawingml/2006/table">
@@ -5497,38 +5467,6 @@
                       <a:r>
                         <a:rPr lang="en-US" sz="2800" b="1" u="none" dirty="0"/>
                         <a:t> restriction site ("GAATTC"), returning the sequence IDs and positions of the sites for downstream genetic analysis.</a:t>
-                      </a:r>
-                    </a:p>
-                    <a:p>
-                      <a:pPr algn="ctr"/>
-                      <a:endParaRPr lang="en-US" sz="1800" b="1" u="none" dirty="0"/>
-                    </a:p>
-                    <a:p>
-                      <a:pPr algn="ctr"/>
-                      <a:r>
-                        <a:rPr lang="en-US" sz="2800" b="1" u="none" dirty="0"/>
-                        <a:t>Do you have any specific thresholds or filters?</a:t>
-                      </a:r>
-                    </a:p>
-                    <a:p>
-                      <a:pPr algn="ctr"/>
-                      <a:r>
-                        <a:rPr lang="en-US" sz="2800" b="1" u="none" dirty="0"/>
-                        <a:t>  [1] Use defaults</a:t>
-                      </a:r>
-                    </a:p>
-                    <a:p>
-                      <a:pPr algn="ctr"/>
-                      <a:r>
-                        <a:rPr lang="en-US" sz="2800" b="1" u="none" dirty="0"/>
-                        <a:t>  [2] Specify my own</a:t>
-                      </a:r>
-                    </a:p>
-                    <a:p>
-                      <a:pPr algn="ctr"/>
-                      <a:r>
-                        <a:rPr lang="en-US" sz="2800" b="1" u="none" dirty="0"/>
-                        <a:t>Select (1 or 2): 1</a:t>
                       </a:r>
                     </a:p>
                     <a:p>
@@ -6297,8 +6235,8 @@
         </p:nvSpPr>
         <p:spPr>
           <a:xfrm>
-            <a:off x="1371598" y="7926787"/>
-            <a:ext cx="13271537" cy="5632311"/>
+            <a:off x="957945" y="7926787"/>
+            <a:ext cx="13961655" cy="8956298"/>
           </a:xfrm>
           <a:prstGeom prst="rect">
             <a:avLst/>
@@ -6317,7 +6255,7 @@
             </a:pPr>
             <a:r>
               <a:rPr lang="en-US" sz="3600" dirty="0"/>
-              <a:t>Develop a functional multi-agent AI system using open-source large language models (LLMs) capable of processing, coding, and interpreting genomic datasets.</a:t>
+              <a:t>Professionals in medicine, forensics, and pharmacology increasingly need to extract insights from genomic data, but doing so requires specialized bioinformatics training and programming expertise they do not have.</a:t>
             </a:r>
           </a:p>
           <a:p>
@@ -6327,7 +6265,23 @@
             </a:pPr>
             <a:r>
               <a:rPr lang="en-US" sz="3600" dirty="0"/>
-              <a:t>Design and implement an AI-based tool that can automatically generate and execute Python code for bioinformatic tasks.</a:t>
+              <a:t>Existing tools like </a:t>
+            </a:r>
+            <a:r>
+              <a:rPr lang="en-US" sz="3600" dirty="0" err="1"/>
+              <a:t>Biopython</a:t>
+            </a:r>
+            <a:r>
+              <a:rPr lang="en-US" sz="3600" dirty="0"/>
+              <a:t> and </a:t>
+            </a:r>
+            <a:r>
+              <a:rPr lang="en-US" sz="3600" dirty="0" err="1"/>
+              <a:t>Bioperl</a:t>
+            </a:r>
+            <a:r>
+              <a:rPr lang="en-US" sz="3600" dirty="0"/>
+              <a:t> still demand manual setup and coding knowledge, leaving no private AI-driven solution for users who understand their data but cannot write analysis scripts from scratch.</a:t>
             </a:r>
           </a:p>
           <a:p>
@@ -6337,7 +6291,7 @@
             </a:pPr>
             <a:r>
               <a:rPr lang="en-US" sz="3600" dirty="0"/>
-              <a:t>Deliver accurate and reliable solutions generated by the AI system.</a:t>
+              <a:t>We developed a multi-agent AI system that allows users to provide a genomic dataset and describe their analysis goal in plain English. This system automatically generates, debugs, and executes Python code, returning clear and interpretable results.</a:t>
             </a:r>
           </a:p>
           <a:p>
@@ -6347,74 +6301,8 @@
             </a:pPr>
             <a:r>
               <a:rPr lang="en-US" sz="3600" dirty="0"/>
-              <a:t>Reduce time required to process and interpret data by 50% compared to traditional bioinformatic workflows.</a:t>
+              <a:t>The system supports standard genomic file formats, and aims to reduce the time required to go from raw data to actionable insight by at least 50% compared to traditional bioinformatic workflows that depend on a specialist.</a:t>
             </a:r>
-          </a:p>
-        </p:txBody>
-      </p:sp>
-      <p:sp>
-        <p:nvSpPr>
-          <p:cNvPr id="7" name="TextBox 6">
-            <a:extLst>
-              <a:ext uri="{FF2B5EF4-FFF2-40B4-BE49-F238E27FC236}">
-                <a16:creationId xmlns:a16="http://schemas.microsoft.com/office/drawing/2014/main" id="{FBFFED9C-0D6A-AF0D-00C8-0F6D0489D213}"/>
-              </a:ext>
-            </a:extLst>
-          </p:cNvPr>
-          <p:cNvSpPr txBox="1"/>
-          <p:nvPr/>
-        </p:nvSpPr>
-        <p:spPr>
-          <a:xfrm>
-            <a:off x="1371599" y="15166193"/>
-            <a:ext cx="13271534" cy="5078313"/>
-          </a:xfrm>
-          <a:prstGeom prst="rect">
-            <a:avLst/>
-          </a:prstGeom>
-          <a:noFill/>
-        </p:spPr>
-        <p:txBody>
-          <a:bodyPr wrap="square" rtlCol="0">
-            <a:spAutoFit/>
-          </a:bodyPr>
-          <a:lstStyle/>
-          <a:p>
-            <a:pPr marL="571500" indent="-571500">
-              <a:buFont typeface="Arial" panose="020B0604020202020204" pitchFamily="34" charset="0"/>
-              <a:buChar char="•"/>
-            </a:pPr>
-            <a:r>
-              <a:rPr lang="en-US" sz="3600" dirty="0"/>
-              <a:t>Bioinformatic tasks dealing with large datasets are complex and required domain knowledge.</a:t>
-            </a:r>
-          </a:p>
-          <a:p>
-            <a:pPr marL="571500" indent="-571500">
-              <a:buFont typeface="Arial" panose="020B0604020202020204" pitchFamily="34" charset="0"/>
-              <a:buChar char="•"/>
-            </a:pPr>
-            <a:r>
-              <a:rPr lang="en-US" sz="3600" dirty="0"/>
-              <a:t>The goal of the agent is to simplify this process for non-bioinformaticians working on genomic datasets that often require a bioinformatician to decipher.</a:t>
-            </a:r>
-          </a:p>
-          <a:p>
-            <a:pPr marL="571500" indent="-571500">
-              <a:buFont typeface="Arial" panose="020B0604020202020204" pitchFamily="34" charset="0"/>
-              <a:buChar char="•"/>
-            </a:pPr>
-            <a:r>
-              <a:rPr lang="en-US" sz="3600" dirty="0"/>
-              <a:t>To solve this problem, we propose a multi-agent AI system capable of reading genomic data, analyzing it, and producing useful and understandable insights. </a:t>
-            </a:r>
-          </a:p>
-          <a:p>
-            <a:pPr marL="571500" indent="-571500">
-              <a:buFont typeface="Arial" panose="020B0604020202020204" pitchFamily="34" charset="0"/>
-              <a:buChar char="•"/>
-            </a:pPr>
-            <a:endParaRPr lang="en-US" sz="3600" dirty="0"/>
           </a:p>
         </p:txBody>
       </p:sp>
@@ -6432,8 +6320,8 @@
         </p:nvSpPr>
         <p:spPr>
           <a:xfrm>
-            <a:off x="15406501" y="8066907"/>
-            <a:ext cx="12154755" cy="3970318"/>
+            <a:off x="15404831" y="7801110"/>
+            <a:ext cx="12482698" cy="4524315"/>
           </a:xfrm>
           <a:prstGeom prst="rect">
             <a:avLst/>
@@ -6452,7 +6340,7 @@
             </a:pPr>
             <a:r>
               <a:rPr lang="en-US" sz="3600" dirty="0"/>
-              <a:t>Model must run on NVDIA A100 GPU 40GB.</a:t>
+              <a:t>Model must run on a single NVDIA A100 GPU 40GB VRAM provided by VCU.</a:t>
             </a:r>
           </a:p>
           <a:p>
@@ -6462,7 +6350,7 @@
             </a:pPr>
             <a:r>
               <a:rPr lang="en-US" sz="3600" dirty="0"/>
-              <a:t>LLMs parameter sizes limited to 20 Billion.</a:t>
+              <a:t>LLMs capped at 20 billion parameters to fit in memory.</a:t>
             </a:r>
           </a:p>
           <a:p>
@@ -6472,7 +6360,7 @@
             </a:pPr>
             <a:r>
               <a:rPr lang="en-US" sz="3600" dirty="0"/>
-              <a:t>Open Source, trustworthy LLMs only.</a:t>
+              <a:t>Open Source, permissively license models only.</a:t>
             </a:r>
           </a:p>
           <a:p>
@@ -6482,7 +6370,7 @@
             </a:pPr>
             <a:r>
               <a:rPr lang="en-US" sz="3600" dirty="0"/>
-              <a:t>Reasonable completion speed for output.</a:t>
+              <a:t>Autonomously generate, debug, and re-attempt code up to 3 times.</a:t>
             </a:r>
           </a:p>
           <a:p>
@@ -6492,7 +6380,7 @@
             </a:pPr>
             <a:r>
               <a:rPr lang="en-US" sz="3600" dirty="0"/>
-              <a:t>Agents must debug and produce runnable python code.</a:t>
+              <a:t>Handle FASTA, VCF, and CSV/TSV without data loss.</a:t>
             </a:r>
           </a:p>
           <a:p>
@@ -6502,7 +6390,7 @@
             </a:pPr>
             <a:r>
               <a:rPr lang="en-US" sz="3600" dirty="0"/>
-              <a:t>Agents must be able to write code to process typical file formats for bioinformatics (FASTA, FASTQ, VCF).</a:t>
+              <a:t>Analyses must complete in minutes, not hours.</a:t>
             </a:r>
           </a:p>
         </p:txBody>
@@ -6521,8 +6409,8 @@
         </p:nvSpPr>
         <p:spPr>
           <a:xfrm>
-            <a:off x="15406499" y="13748795"/>
-            <a:ext cx="12154758" cy="5509200"/>
+            <a:off x="15404831" y="13761937"/>
+            <a:ext cx="12638290" cy="5293757"/>
           </a:xfrm>
           <a:prstGeom prst="rect">
             <a:avLst/>
@@ -6541,7 +6429,7 @@
             </a:pPr>
             <a:r>
               <a:rPr lang="en-US" sz="3600" dirty="0"/>
-              <a:t>One LLM was chosen for both writing and coding agents for current prototyping simplicity.</a:t>
+              <a:t>Llama 3.1 Pro Coder (8B parameters) powers bot the Writer and Coder agents.</a:t>
             </a:r>
           </a:p>
           <a:p>
@@ -6551,7 +6439,7 @@
             </a:pPr>
             <a:r>
               <a:rPr lang="en-US" sz="3600" dirty="0"/>
-              <a:t>We chose the LLM, Code Llama, because it is a coding focused model with adequate writing abilities.</a:t>
+              <a:t>One model, simpler deployment, lower memory footprint.</a:t>
             </a:r>
           </a:p>
           <a:p>
@@ -6561,7 +6449,15 @@
             </a:pPr>
             <a:r>
               <a:rPr lang="en-US" sz="3600" dirty="0"/>
-              <a:t>Current LLM instructions were written to focus primarily on Python code.</a:t>
+              <a:t>NF4 4-bit quantization via </a:t>
+            </a:r>
+            <a:r>
+              <a:rPr lang="en-US" sz="3600" dirty="0" err="1"/>
+              <a:t>BitsAndBytes</a:t>
+            </a:r>
+            <a:r>
+              <a:rPr lang="en-US" sz="3600" dirty="0"/>
+              <a:t> cuts memory usage ~75%.</a:t>
             </a:r>
           </a:p>
           <a:p>
@@ -6571,13 +6467,32 @@
             </a:pPr>
             <a:r>
               <a:rPr lang="en-US" sz="3600" dirty="0"/>
-              <a:t>The models will write Python code because of the vast amounts of data processing libraries and capabilities to easily work with users input.</a:t>
+              <a:t>Python as the target language for its dominance in bioinformatics (</a:t>
+            </a:r>
+            <a:r>
+              <a:rPr lang="en-US" sz="3600" dirty="0" err="1"/>
+              <a:t>Biopython</a:t>
+            </a:r>
+            <a:r>
+              <a:rPr lang="en-US" sz="3600" dirty="0"/>
+              <a:t>, pandas, NumPy).</a:t>
             </a:r>
           </a:p>
           <a:p>
-            <a:br>
-              <a:rPr lang="en-US" dirty="0"/>
-            </a:br>
+            <a:pPr marL="571500" indent="-571500">
+              <a:buFont typeface="Arial" panose="020B0604020202020204" pitchFamily="34" charset="0"/>
+              <a:buChar char="•"/>
+            </a:pPr>
+            <a:r>
+              <a:rPr lang="en-US" sz="3600" dirty="0"/>
+              <a:t>All generated code runs in an isolated sandbox with its own virtual environment.</a:t>
+            </a:r>
+          </a:p>
+          <a:p>
+            <a:pPr marL="571500" indent="-571500">
+              <a:buFont typeface="Arial" panose="020B0604020202020204" pitchFamily="34" charset="0"/>
+              <a:buChar char="•"/>
+            </a:pPr>
             <a:endParaRPr lang="en-US" dirty="0"/>
           </a:p>
         </p:txBody>
@@ -6597,9 +6512,9 @@
           <p:nvPr/>
         </p:nvCxnSpPr>
         <p:spPr>
-          <a:xfrm>
-            <a:off x="14919602" y="6670901"/>
-            <a:ext cx="0" cy="13154980"/>
+          <a:xfrm flipH="1">
+            <a:off x="14781052" y="6383867"/>
+            <a:ext cx="107491" cy="24400933"/>
           </a:xfrm>
           <a:prstGeom prst="line">
             <a:avLst/>
@@ -6643,7 +6558,7 @@
         </p:nvSpPr>
         <p:spPr>
           <a:xfrm>
-            <a:off x="1371599" y="6604140"/>
+            <a:off x="957945" y="6603896"/>
             <a:ext cx="13271549" cy="1157050"/>
           </a:xfrm>
           <a:prstGeom prst="roundRect">
@@ -6685,7 +6600,7 @@
                 <a:cs typeface="Arial"/>
                 <a:sym typeface="Arial"/>
               </a:rPr>
-              <a:t>Objective</a:t>
+              <a:t>Problem &amp; Objective</a:t>
             </a:r>
             <a:endParaRPr lang="en-US" b="1" dirty="0">
               <a:solidFill>
@@ -6711,8 +6626,8 @@
         </p:nvCxnSpPr>
         <p:spPr>
           <a:xfrm>
-            <a:off x="1371600" y="6383867"/>
-            <a:ext cx="41176575" cy="0"/>
+            <a:off x="957945" y="6383867"/>
+            <a:ext cx="41590230" cy="0"/>
           </a:xfrm>
           <a:prstGeom prst="line">
             <a:avLst/>
@@ -6744,72 +6659,6 @@
       </p:cxnSp>
       <p:sp>
         <p:nvSpPr>
-          <p:cNvPr id="22" name="Rounded Rectangle 21">
-            <a:extLst>
-              <a:ext uri="{FF2B5EF4-FFF2-40B4-BE49-F238E27FC236}">
-                <a16:creationId xmlns:a16="http://schemas.microsoft.com/office/drawing/2014/main" id="{7BDEB742-33EB-D5F7-B5DD-72CBCCB8998B}"/>
-              </a:ext>
-            </a:extLst>
-          </p:cNvPr>
-          <p:cNvSpPr/>
-          <p:nvPr/>
-        </p:nvSpPr>
-        <p:spPr>
-          <a:xfrm>
-            <a:off x="1371599" y="13782516"/>
-            <a:ext cx="13271539" cy="1157050"/>
-          </a:xfrm>
-          <a:prstGeom prst="roundRect">
-            <a:avLst/>
-          </a:prstGeom>
-        </p:spPr>
-        <p:style>
-          <a:lnRef idx="2">
-            <a:schemeClr val="dk1">
-              <a:shade val="15000"/>
-            </a:schemeClr>
-          </a:lnRef>
-          <a:fillRef idx="1">
-            <a:schemeClr val="dk1"/>
-          </a:fillRef>
-          <a:effectRef idx="0">
-            <a:schemeClr val="dk1"/>
-          </a:effectRef>
-          <a:fontRef idx="minor">
-            <a:schemeClr val="lt1"/>
-          </a:fontRef>
-        </p:style>
-        <p:txBody>
-          <a:bodyPr rtlCol="0" anchor="ctr"/>
-          <a:lstStyle/>
-          <a:p>
-            <a:r>
-              <a:rPr kumimoji="0" lang="en-US" sz="4800" b="1" i="0" u="none" strike="noStrike" kern="0" cap="none" spc="0" normalizeH="0" baseline="0" noProof="0" dirty="0">
-                <a:ln>
-                  <a:noFill/>
-                </a:ln>
-                <a:solidFill>
-                  <a:schemeClr val="bg1"/>
-                </a:solidFill>
-                <a:effectLst/>
-                <a:uLnTx/>
-                <a:uFillTx/>
-                <a:latin typeface="Arial"/>
-                <a:cs typeface="Arial"/>
-                <a:sym typeface="Arial"/>
-              </a:rPr>
-              <a:t>Problem</a:t>
-            </a:r>
-            <a:endParaRPr lang="en-US" b="1" dirty="0">
-              <a:solidFill>
-                <a:schemeClr val="bg1"/>
-              </a:solidFill>
-            </a:endParaRPr>
-          </a:p>
-        </p:txBody>
-      </p:sp>
-      <p:sp>
-        <p:nvSpPr>
           <p:cNvPr id="23" name="Rounded Rectangle 22">
             <a:extLst>
               <a:ext uri="{FF2B5EF4-FFF2-40B4-BE49-F238E27FC236}">
@@ -6822,8 +6671,8 @@
         </p:nvSpPr>
         <p:spPr>
           <a:xfrm>
-            <a:off x="15406505" y="6664089"/>
-            <a:ext cx="12154755" cy="1157050"/>
+            <a:off x="15404834" y="6493509"/>
+            <a:ext cx="12482695" cy="1157050"/>
           </a:xfrm>
           <a:prstGeom prst="roundRect">
             <a:avLst/>
@@ -6870,8 +6719,8 @@
         </p:nvSpPr>
         <p:spPr>
           <a:xfrm>
-            <a:off x="15406499" y="12314485"/>
-            <a:ext cx="12154758" cy="1157050"/>
+            <a:off x="15404831" y="12435066"/>
+            <a:ext cx="12431218" cy="1157050"/>
           </a:xfrm>
           <a:prstGeom prst="roundRect">
             <a:avLst/>
@@ -6904,53 +6753,6 @@
           </a:p>
         </p:txBody>
       </p:sp>
-      <p:cxnSp>
-        <p:nvCxnSpPr>
-          <p:cNvPr id="26" name="Straight Connector 25">
-            <a:extLst>
-              <a:ext uri="{FF2B5EF4-FFF2-40B4-BE49-F238E27FC236}">
-                <a16:creationId xmlns:a16="http://schemas.microsoft.com/office/drawing/2014/main" id="{DFC53538-A8F5-4438-3409-53BB8AB5C303}"/>
-              </a:ext>
-            </a:extLst>
-          </p:cNvPr>
-          <p:cNvCxnSpPr>
-            <a:cxnSpLocks/>
-          </p:cNvCxnSpPr>
-          <p:nvPr/>
-        </p:nvCxnSpPr>
-        <p:spPr>
-          <a:xfrm>
-            <a:off x="1371599" y="20045909"/>
-            <a:ext cx="26517601" cy="0"/>
-          </a:xfrm>
-          <a:prstGeom prst="line">
-            <a:avLst/>
-          </a:prstGeom>
-          <a:ln w="19050" cap="flat" cmpd="sng" algn="ctr">
-            <a:solidFill>
-              <a:schemeClr val="dk1"/>
-            </a:solidFill>
-            <a:prstDash val="dash"/>
-            <a:round/>
-            <a:headEnd type="none" w="med" len="med"/>
-            <a:tailEnd type="none" w="med" len="med"/>
-          </a:ln>
-        </p:spPr>
-        <p:style>
-          <a:lnRef idx="0">
-            <a:scrgbClr r="0" g="0" b="0"/>
-          </a:lnRef>
-          <a:fillRef idx="0">
-            <a:scrgbClr r="0" g="0" b="0"/>
-          </a:fillRef>
-          <a:effectRef idx="0">
-            <a:scrgbClr r="0" g="0" b="0"/>
-          </a:effectRef>
-          <a:fontRef idx="minor">
-            <a:schemeClr val="tx1"/>
-          </a:fontRef>
-        </p:style>
-      </p:cxnSp>
       <p:sp>
         <p:nvSpPr>
           <p:cNvPr id="32" name="Rounded Rectangle 31">
@@ -6965,8 +6767,8 @@
         </p:nvSpPr>
         <p:spPr>
           <a:xfrm>
-            <a:off x="9995809" y="20471133"/>
-            <a:ext cx="12515849" cy="1157050"/>
+            <a:off x="1231630" y="17344912"/>
+            <a:ext cx="12997864" cy="1157050"/>
           </a:xfrm>
           <a:prstGeom prst="roundRect">
             <a:avLst/>
@@ -6992,7 +6794,6 @@
           <a:bodyPr rtlCol="0" anchor="ctr"/>
           <a:lstStyle/>
           <a:p>
-            <a:pPr algn="ctr"/>
             <a:r>
               <a:rPr lang="en-US" sz="4800" b="1" dirty="0"/>
               <a:t>Final Design</a:t>
@@ -7063,9 +6864,9 @@
           <p:nvPr/>
         </p:nvCxnSpPr>
         <p:spPr>
-          <a:xfrm>
-            <a:off x="27890865" y="6670901"/>
-            <a:ext cx="0" cy="13154980"/>
+          <a:xfrm flipH="1">
+            <a:off x="28004643" y="6383867"/>
+            <a:ext cx="164380" cy="24400933"/>
           </a:xfrm>
           <a:prstGeom prst="line">
             <a:avLst/>
@@ -7095,6 +6896,279 @@
           </a:fontRef>
         </p:style>
       </p:cxnSp>
+      <p:pic>
+        <p:nvPicPr>
+          <p:cNvPr id="12" name="Picture 11">
+            <a:extLst>
+              <a:ext uri="{FF2B5EF4-FFF2-40B4-BE49-F238E27FC236}">
+                <a16:creationId xmlns:a16="http://schemas.microsoft.com/office/drawing/2014/main" id="{BBE3FC3E-1A02-432F-7AFF-BE4FF9B5EF04}"/>
+              </a:ext>
+            </a:extLst>
+          </p:cNvPr>
+          <p:cNvPicPr>
+            <a:picLocks noChangeAspect="1"/>
+          </p:cNvPicPr>
+          <p:nvPr/>
+        </p:nvPicPr>
+        <p:blipFill>
+          <a:blip r:embed="rId4"/>
+          <a:stretch>
+            <a:fillRect/>
+          </a:stretch>
+        </p:blipFill>
+        <p:spPr>
+          <a:xfrm>
+            <a:off x="1231630" y="19039312"/>
+            <a:ext cx="11783864" cy="10713179"/>
+          </a:xfrm>
+          <a:prstGeom prst="rect">
+            <a:avLst/>
+          </a:prstGeom>
+        </p:spPr>
+      </p:pic>
+      <p:sp>
+        <p:nvSpPr>
+          <p:cNvPr id="18" name="Rounded Rectangle 23">
+            <a:extLst>
+              <a:ext uri="{FF2B5EF4-FFF2-40B4-BE49-F238E27FC236}">
+                <a16:creationId xmlns:a16="http://schemas.microsoft.com/office/drawing/2014/main" id="{6C2E6136-EBD0-91EF-F49C-73CA96D75E65}"/>
+              </a:ext>
+            </a:extLst>
+          </p:cNvPr>
+          <p:cNvSpPr/>
+          <p:nvPr/>
+        </p:nvSpPr>
+        <p:spPr>
+          <a:xfrm>
+            <a:off x="15373772" y="18764666"/>
+            <a:ext cx="12431218" cy="1157050"/>
+          </a:xfrm>
+          <a:prstGeom prst="roundRect">
+            <a:avLst/>
+          </a:prstGeom>
+        </p:spPr>
+        <p:style>
+          <a:lnRef idx="2">
+            <a:schemeClr val="dk1">
+              <a:shade val="15000"/>
+            </a:schemeClr>
+          </a:lnRef>
+          <a:fillRef idx="1">
+            <a:schemeClr val="dk1"/>
+          </a:fillRef>
+          <a:effectRef idx="0">
+            <a:schemeClr val="dk1"/>
+          </a:effectRef>
+          <a:fontRef idx="minor">
+            <a:schemeClr val="lt1"/>
+          </a:fontRef>
+        </p:style>
+        <p:txBody>
+          <a:bodyPr rtlCol="0" anchor="ctr"/>
+          <a:lstStyle/>
+          <a:p>
+            <a:r>
+              <a:rPr lang="en-US" sz="4800" b="1" dirty="0"/>
+              <a:t>Limitations</a:t>
+            </a:r>
+          </a:p>
+        </p:txBody>
+      </p:sp>
+      <p:sp>
+        <p:nvSpPr>
+          <p:cNvPr id="20" name="TextBox 19">
+            <a:extLst>
+              <a:ext uri="{FF2B5EF4-FFF2-40B4-BE49-F238E27FC236}">
+                <a16:creationId xmlns:a16="http://schemas.microsoft.com/office/drawing/2014/main" id="{27998D33-F1B4-729D-C6A8-051FDA508249}"/>
+              </a:ext>
+            </a:extLst>
+          </p:cNvPr>
+          <p:cNvSpPr txBox="1"/>
+          <p:nvPr/>
+        </p:nvSpPr>
+        <p:spPr>
+          <a:xfrm>
+            <a:off x="15311655" y="20031357"/>
+            <a:ext cx="12493335" cy="6186309"/>
+          </a:xfrm>
+          <a:prstGeom prst="rect">
+            <a:avLst/>
+          </a:prstGeom>
+          <a:noFill/>
+        </p:spPr>
+        <p:txBody>
+          <a:bodyPr wrap="square" lIns="91440" tIns="45720" rIns="91440" bIns="45720" rtlCol="0" anchor="t">
+            <a:spAutoFit/>
+          </a:bodyPr>
+          <a:lstStyle/>
+          <a:p>
+            <a:pPr marL="571500" indent="-571500">
+              <a:buFont typeface="Arial" panose="020B0604020202020204" pitchFamily="34" charset="0"/>
+              <a:buChar char="•"/>
+            </a:pPr>
+            <a:r>
+              <a:rPr lang="en-US" sz="3600" dirty="0"/>
+              <a:t>Only Supports FASTA, VCF, and CSV/TSV – no FASTQ or BAM files.</a:t>
+            </a:r>
+          </a:p>
+          <a:p>
+            <a:pPr marL="571500" indent="-571500">
+              <a:buFont typeface="Arial" panose="020B0604020202020204" pitchFamily="34" charset="0"/>
+              <a:buChar char="•"/>
+            </a:pPr>
+            <a:r>
+              <a:rPr lang="en-US" sz="3600" dirty="0"/>
+              <a:t>The LLM may generate incorrect code that passes execution but produces biologically wrong results – always verify outputs.</a:t>
+            </a:r>
+          </a:p>
+          <a:p>
+            <a:pPr marL="571500" indent="-571500">
+              <a:buFont typeface="Arial" panose="020B0604020202020204" pitchFamily="34" charset="0"/>
+              <a:buChar char="•"/>
+            </a:pPr>
+            <a:r>
+              <a:rPr lang="en-US" sz="3600" dirty="0"/>
+              <a:t>Limited to single-file inputs; multi-file or pipeline workflows are not supported</a:t>
+            </a:r>
+          </a:p>
+          <a:p>
+            <a:pPr marL="571500" indent="-571500">
+              <a:buFont typeface="Arial" panose="020B0604020202020204" pitchFamily="34" charset="0"/>
+              <a:buChar char="•"/>
+            </a:pPr>
+            <a:r>
+              <a:rPr lang="en-US" sz="3600" dirty="0"/>
+              <a:t>Large datasets may exceed memory or cause long runtimes.</a:t>
+            </a:r>
+          </a:p>
+          <a:p>
+            <a:pPr marL="571500" indent="-571500">
+              <a:buFont typeface="Arial" panose="020B0604020202020204" pitchFamily="34" charset="0"/>
+              <a:buChar char="•"/>
+            </a:pPr>
+            <a:r>
+              <a:rPr lang="en-US" sz="3600" dirty="0"/>
+              <a:t>Analyses are limited to what Python libraries can accomplish in a single script.</a:t>
+            </a:r>
+            <a:endParaRPr lang="en-US" dirty="0"/>
+          </a:p>
+        </p:txBody>
+      </p:sp>
+      <p:sp>
+        <p:nvSpPr>
+          <p:cNvPr id="25" name="Rounded Rectangle 23">
+            <a:extLst>
+              <a:ext uri="{FF2B5EF4-FFF2-40B4-BE49-F238E27FC236}">
+                <a16:creationId xmlns:a16="http://schemas.microsoft.com/office/drawing/2014/main" id="{177E1F27-3575-1993-1ED9-7936CC66779B}"/>
+              </a:ext>
+            </a:extLst>
+          </p:cNvPr>
+          <p:cNvSpPr/>
+          <p:nvPr/>
+        </p:nvSpPr>
+        <p:spPr>
+          <a:xfrm>
+            <a:off x="15265753" y="26360957"/>
+            <a:ext cx="12431218" cy="1157050"/>
+          </a:xfrm>
+          <a:prstGeom prst="roundRect">
+            <a:avLst/>
+          </a:prstGeom>
+        </p:spPr>
+        <p:style>
+          <a:lnRef idx="2">
+            <a:schemeClr val="dk1">
+              <a:shade val="15000"/>
+            </a:schemeClr>
+          </a:lnRef>
+          <a:fillRef idx="1">
+            <a:schemeClr val="dk1"/>
+          </a:fillRef>
+          <a:effectRef idx="0">
+            <a:schemeClr val="dk1"/>
+          </a:effectRef>
+          <a:fontRef idx="minor">
+            <a:schemeClr val="lt1"/>
+          </a:fontRef>
+        </p:style>
+        <p:txBody>
+          <a:bodyPr rtlCol="0" anchor="ctr"/>
+          <a:lstStyle/>
+          <a:p>
+            <a:r>
+              <a:rPr lang="en-US" sz="4800" b="1" dirty="0"/>
+              <a:t>How to run</a:t>
+            </a:r>
+          </a:p>
+        </p:txBody>
+      </p:sp>
+      <p:sp>
+        <p:nvSpPr>
+          <p:cNvPr id="27" name="TextBox 26">
+            <a:extLst>
+              <a:ext uri="{FF2B5EF4-FFF2-40B4-BE49-F238E27FC236}">
+                <a16:creationId xmlns:a16="http://schemas.microsoft.com/office/drawing/2014/main" id="{AF995B24-3B2C-9CCA-E427-E4123DF00A34}"/>
+              </a:ext>
+            </a:extLst>
+          </p:cNvPr>
+          <p:cNvSpPr txBox="1"/>
+          <p:nvPr/>
+        </p:nvSpPr>
+        <p:spPr>
+          <a:xfrm>
+            <a:off x="15234695" y="27661298"/>
+            <a:ext cx="12493335" cy="2862322"/>
+          </a:xfrm>
+          <a:prstGeom prst="rect">
+            <a:avLst/>
+          </a:prstGeom>
+          <a:noFill/>
+        </p:spPr>
+        <p:txBody>
+          <a:bodyPr wrap="square" lIns="91440" tIns="45720" rIns="91440" bIns="45720" rtlCol="0" anchor="t">
+            <a:spAutoFit/>
+          </a:bodyPr>
+          <a:lstStyle/>
+          <a:p>
+            <a:pPr marL="571500" indent="-571500">
+              <a:buFont typeface="Arial" panose="020B0604020202020204" pitchFamily="34" charset="0"/>
+              <a:buChar char="•"/>
+            </a:pPr>
+            <a:r>
+              <a:rPr lang="en-US" sz="3600" dirty="0"/>
+              <a:t>Place your data file in the input/ folder and run:                      python3 main.py input/&lt;</a:t>
+            </a:r>
+            <a:r>
+              <a:rPr lang="en-US" sz="3600" dirty="0" err="1"/>
+              <a:t>your_file</a:t>
+            </a:r>
+            <a:r>
+              <a:rPr lang="en-US" sz="3600" dirty="0"/>
+              <a:t>&gt;</a:t>
+            </a:r>
+          </a:p>
+          <a:p>
+            <a:pPr marL="571500" indent="-571500">
+              <a:buFont typeface="Arial" panose="020B0604020202020204" pitchFamily="34" charset="0"/>
+              <a:buChar char="•"/>
+            </a:pPr>
+            <a:r>
+              <a:rPr lang="en-US" sz="3600" dirty="0"/>
+              <a:t>Select a preset analysis or describe or own.</a:t>
+            </a:r>
+          </a:p>
+          <a:p>
+            <a:pPr marL="571500" indent="-571500">
+              <a:buFont typeface="Arial" panose="020B0604020202020204" pitchFamily="34" charset="0"/>
+              <a:buChar char="•"/>
+            </a:pPr>
+            <a:r>
+              <a:rPr lang="en-US" sz="3600" dirty="0"/>
+              <a:t>Results display in the terminal and the generate script saves to output/solution.py</a:t>
+            </a:r>
+          </a:p>
+        </p:txBody>
+      </p:sp>
     </p:spTree>
   </p:cSld>
   <p:clrMapOvr>

</xml_diff>